<commit_message>
perubahan pada link ppt
</commit_message>
<xml_diff>
--- a/KAI Pipeline Bronze layer/KAI-Bronze table ticketing.pptx
+++ b/KAI Pipeline Bronze layer/KAI-Bronze table ticketing.pptx
@@ -10309,11 +10309,11 @@
               <a:t> </a:t>
             </a:r>
             <a:r>
-              <a:rPr lang="en-US" sz="1600"/>
+              <a:rPr lang="en-US" sz="1600" dirty="0"/>
               <a:t>: </a:t>
             </a:r>
             <a:r>
-              <a:rPr lang="en-US" sz="1600">
+              <a:rPr lang="en-US" sz="1600" dirty="0">
                 <a:hlinkClick r:id="rId4"/>
               </a:rPr>
               <a:t>Query Init Program</a:t>
@@ -10978,6 +10978,19 @@
 </file>
 
 <file path=customXml/item1.xml><?xml version="1.0" encoding="utf-8"?>
+<p:properties xmlns:p="http://schemas.microsoft.com/office/2006/metadata/properties" xmlns:xsi="http://www.w3.org/2001/XMLSchema-instance" xmlns:pc="http://schemas.microsoft.com/office/infopath/2007/PartnerControls">
+  <documentManagement>
+    <lcf76f155ced4ddcb4097134ff3c332f xmlns="bc5625e7-241d-4c01-9664-76b2c0bd8c53">
+      <Terms xmlns="http://schemas.microsoft.com/office/infopath/2007/PartnerControls"/>
+    </lcf76f155ced4ddcb4097134ff3c332f>
+    <ExamCode xmlns="bc5625e7-241d-4c01-9664-76b2c0bd8c53" xsi:nil="true"/>
+    <TaxCatchAll xmlns="e01f04f6-20fd-4f8d-8872-a1a8db49c627" xsi:nil="true"/>
+    <IssuingOrg xmlns="bc5625e7-241d-4c01-9664-76b2c0bd8c53" xsi:nil="true"/>
+  </documentManagement>
+</p:properties>
+</file>
+
+<file path=customXml/item2.xml><?xml version="1.0" encoding="utf-8"?>
 <ct:contentTypeSchema xmlns:ct="http://schemas.microsoft.com/office/2006/metadata/contentType" xmlns:ma="http://schemas.microsoft.com/office/2006/metadata/properties/metaAttributes" ct:_="" ma:_="" ma:contentTypeName="Document" ma:contentTypeID="0x010100D50E25D9177334429EAEE74A444A630A" ma:contentTypeVersion="16" ma:contentTypeDescription="Create a new document." ma:contentTypeScope="" ma:versionID="d1e6bf55b23d7f02cc74b4d3f56c26dd">
   <xsd:schema xmlns:xsd="http://www.w3.org/2001/XMLSchema" xmlns:xs="http://www.w3.org/2001/XMLSchema" xmlns:p="http://schemas.microsoft.com/office/2006/metadata/properties" xmlns:ns2="bc5625e7-241d-4c01-9664-76b2c0bd8c53" xmlns:ns3="e01f04f6-20fd-4f8d-8872-a1a8db49c627" targetNamespace="http://schemas.microsoft.com/office/2006/metadata/properties" ma:root="true" ma:fieldsID="0e3dfdcbff00e4660cb2686566bb134f" ns2:_="" ns3:_="">
     <xsd:import namespace="bc5625e7-241d-4c01-9664-76b2c0bd8c53"/>
@@ -11222,19 +11235,6 @@
 </ct:contentTypeSchema>
 </file>
 
-<file path=customXml/item2.xml><?xml version="1.0" encoding="utf-8"?>
-<p:properties xmlns:p="http://schemas.microsoft.com/office/2006/metadata/properties" xmlns:xsi="http://www.w3.org/2001/XMLSchema-instance" xmlns:pc="http://schemas.microsoft.com/office/infopath/2007/PartnerControls">
-  <documentManagement>
-    <lcf76f155ced4ddcb4097134ff3c332f xmlns="bc5625e7-241d-4c01-9664-76b2c0bd8c53">
-      <Terms xmlns="http://schemas.microsoft.com/office/infopath/2007/PartnerControls"/>
-    </lcf76f155ced4ddcb4097134ff3c332f>
-    <ExamCode xmlns="bc5625e7-241d-4c01-9664-76b2c0bd8c53" xsi:nil="true"/>
-    <TaxCatchAll xmlns="e01f04f6-20fd-4f8d-8872-a1a8db49c627" xsi:nil="true"/>
-    <IssuingOrg xmlns="bc5625e7-241d-4c01-9664-76b2c0bd8c53" xsi:nil="true"/>
-  </documentManagement>
-</p:properties>
-</file>
-
 <file path=customXml/item3.xml><?xml version="1.0" encoding="utf-8"?>
 <?mso-contentType ?>
 <FormTemplates xmlns="http://schemas.microsoft.com/sharepoint/v3/contenttype/forms">
@@ -11245,6 +11245,17 @@
 </file>
 
 <file path=customXml/itemProps1.xml><?xml version="1.0" encoding="utf-8"?>
+<ds:datastoreItem xmlns:ds="http://schemas.openxmlformats.org/officeDocument/2006/customXml" ds:itemID="{31A8E4B5-CCFA-4220-A916-0D62ECEA7563}">
+  <ds:schemaRefs>
+    <ds:schemaRef ds:uri="http://schemas.microsoft.com/office/2006/metadata/properties"/>
+    <ds:schemaRef ds:uri="http://schemas.microsoft.com/office/infopath/2007/PartnerControls"/>
+    <ds:schemaRef ds:uri="bc5625e7-241d-4c01-9664-76b2c0bd8c53"/>
+    <ds:schemaRef ds:uri="e01f04f6-20fd-4f8d-8872-a1a8db49c627"/>
+  </ds:schemaRefs>
+</ds:datastoreItem>
+</file>
+
+<file path=customXml/itemProps2.xml><?xml version="1.0" encoding="utf-8"?>
 <ds:datastoreItem xmlns:ds="http://schemas.openxmlformats.org/officeDocument/2006/customXml" ds:itemID="{3A9C4ED3-571E-40A5-89FC-BEE91CB1AD92}">
   <ds:schemaRefs>
     <ds:schemaRef ds:uri="http://schemas.microsoft.com/office/2006/metadata/contentType"/>
@@ -11263,17 +11274,6 @@
 </ds:datastoreItem>
 </file>
 
-<file path=customXml/itemProps2.xml><?xml version="1.0" encoding="utf-8"?>
-<ds:datastoreItem xmlns:ds="http://schemas.openxmlformats.org/officeDocument/2006/customXml" ds:itemID="{31A8E4B5-CCFA-4220-A916-0D62ECEA7563}">
-  <ds:schemaRefs>
-    <ds:schemaRef ds:uri="http://schemas.microsoft.com/office/2006/metadata/properties"/>
-    <ds:schemaRef ds:uri="http://schemas.microsoft.com/office/infopath/2007/PartnerControls"/>
-    <ds:schemaRef ds:uri="bc5625e7-241d-4c01-9664-76b2c0bd8c53"/>
-    <ds:schemaRef ds:uri="e01f04f6-20fd-4f8d-8872-a1a8db49c627"/>
-  </ds:schemaRefs>
-</ds:datastoreItem>
-</file>
-
 <file path=customXml/itemProps3.xml><?xml version="1.0" encoding="utf-8"?>
 <ds:datastoreItem xmlns:ds="http://schemas.openxmlformats.org/officeDocument/2006/customXml" ds:itemID="{7C837E41-435F-4D57-86FA-A4EFC3B3BF21}">
   <ds:schemaRefs>

</xml_diff>